<commit_message>
chore(presentations): update 712 assessment deck and add its PDF export
Co-Authored-By: Claude Opus 5.5 <noreply@anthropic.com>
</commit_message>
<xml_diff>
--- a/70_Presentations/712_Mid-term_Assessment-0425/硕士中期考核_胡智恒_20260425.pptx
+++ b/70_Presentations/712_Mid-term_Assessment-0425/硕士中期考核_胡智恒_20260425.pptx
@@ -289,7 +289,7 @@
           <a:p>
             <a:r>
               <a:rPr lang="zh-CN" altLang="en-US" dirty="0"/>
-              <a:t>各位老师好,我是2024级硕士研究生胡智恒,专业方向为粒子物理与原子核物理,导师是我们所的王惠仁(ONI HOOI JIN)研究员。</a:t>
+              <a:t>各位老师好,我是2024级硕士研究生胡智恒,专业方向为粒子物理与原子核物理,导师是我们所的王惠仁(ONG HOOI JIN)研究员。</a:t>
             </a:r>
           </a:p>
           <a:p>
@@ -1634,7 +1634,7 @@
                 <a:ea typeface="Microsoft YaHei" pitchFamily="34" charset="-122"/>
                 <a:cs typeface="Microsoft YaHei" pitchFamily="34" charset="-120"/>
               </a:rPr>
-              <a:t>(ONI HOOI JIN)</a:t>
+              <a:t>(ONG HOOI JIN)</a:t>
             </a:r>
             <a:r>
               <a:rPr lang="zh-CN" altLang="en-US" sz="1400" kern="0" spc="200" dirty="0">

</xml_diff>